<commit_message>
feat: harden hackathon delivery path
</commit_message>
<xml_diff>
--- a/docs/deck/AttestLock-Hackathon-Deck.pptx
+++ b/docs/deck/AttestLock-Hackathon-Deck.pptx
@@ -2,18 +2,18 @@
 <file path=ppt/presentation.xml><?xml version="1.0" encoding="utf-8"?>
 <p:presentation xmlns:p="http://schemas.openxmlformats.org/presentationml/2006/main">
   <p:sldMasterIdLst>
-    <p:sldMasterId xmlns:r="http://schemas.openxmlformats.org/officeDocument/2006/relationships" id="2147483648" r:id="Rbbf9848bb1cd4e0c"/>
+    <p:sldMasterId xmlns:r="http://schemas.openxmlformats.org/officeDocument/2006/relationships" id="2147483648" r:id="R8666ebce38fb4760"/>
   </p:sldMasterIdLst>
   <p:notesMasterIdLst>
-    <p:notesMasterId xmlns:r="http://schemas.openxmlformats.org/officeDocument/2006/relationships" r:id="Rc857187af7324394"/>
+    <p:notesMasterId xmlns:r="http://schemas.openxmlformats.org/officeDocument/2006/relationships" r:id="R8514c2a29a9e46a9"/>
   </p:notesMasterIdLst>
   <p:sldIdLst>
-    <p:sldId xmlns:r="http://schemas.openxmlformats.org/officeDocument/2006/relationships" id="256" r:id="R827cc1c3e86949df"/>
-    <p:sldId xmlns:r="http://schemas.openxmlformats.org/officeDocument/2006/relationships" id="257" r:id="R92426d51d87b4ab8"/>
-    <p:sldId xmlns:r="http://schemas.openxmlformats.org/officeDocument/2006/relationships" id="258" r:id="Rd2ec0dba8157491b"/>
-    <p:sldId xmlns:r="http://schemas.openxmlformats.org/officeDocument/2006/relationships" id="259" r:id="R7fb5440ea8514e5c"/>
-    <p:sldId xmlns:r="http://schemas.openxmlformats.org/officeDocument/2006/relationships" id="260" r:id="R4f771da9663d4630"/>
-    <p:sldId xmlns:r="http://schemas.openxmlformats.org/officeDocument/2006/relationships" id="261" r:id="R33e17889fe2240ca"/>
+    <p:sldId xmlns:r="http://schemas.openxmlformats.org/officeDocument/2006/relationships" id="256" r:id="R4c38dac249204b08"/>
+    <p:sldId xmlns:r="http://schemas.openxmlformats.org/officeDocument/2006/relationships" id="257" r:id="R48a213f77b1b4fef"/>
+    <p:sldId xmlns:r="http://schemas.openxmlformats.org/officeDocument/2006/relationships" id="258" r:id="R786f4706cdac4e8b"/>
+    <p:sldId xmlns:r="http://schemas.openxmlformats.org/officeDocument/2006/relationships" id="259" r:id="R00f3a0d00907437d"/>
+    <p:sldId xmlns:r="http://schemas.openxmlformats.org/officeDocument/2006/relationships" id="260" r:id="Rcd3578ad2a1c4430"/>
+    <p:sldId xmlns:r="http://schemas.openxmlformats.org/officeDocument/2006/relationships" id="261" r:id="R10e7785e74844063"/>
   </p:sldIdLst>
   <p:sldSz cx="12192000" cy="6858000"/>
   <p:notesSz cx="6858000" cy="9144000"/>
@@ -887,12 +887,12 @@
           </a:p>
           <a:p xmlns:a="http://schemas.openxmlformats.org/drawingml/2006/main">
             <a:r>
-              <a:t>- https://docs.attestcoin.org/ (readability and writability roadmap context; accessed 2026-09-03)</a:t>
-            </a:r>
-          </a:p>
-          <a:p xmlns:a="http://schemas.openxmlformats.org/drawingml/2006/main">
-            <a:r>
-              <a:t>- https://github.com/choguun/AttestLock-Agent/blob/main/docs/THREAT_MODEL.md (V1 limitations; accessed 2026-09-03)</a:t>
+              <a:t>- https://github.com/choguun/AttestLock-Agent/blob/main/docs/MARKET.md (target user, distribution, and ecosystem value; accessed 2026-09-03)</a:t>
+            </a:r>
+          </a:p>
+          <a:p xmlns:a="http://schemas.openxmlformats.org/drawingml/2006/main">
+            <a:r>
+              <a:t>- https://github.com/choguun/AttestLock-Agent/blob/main/docs/THREAT_MODEL.md (V1 limitations and source writability roadmap; accessed 2026-09-03)</a:t>
             </a:r>
           </a:p>
           <a:p xmlns:a="http://schemas.openxmlformats.org/drawingml/2006/main">
@@ -965,7 +965,7 @@
   </p:cSld>
   <p:clrMap bg1="lt1" tx1="dk1" bg2="lt2" tx2="dk2" accent1="accent1" accent2="accent2" accent3="accent3" accent4="accent4" accent5="accent5" accent6="accent6" hlink="hlink" folHlink="folHlink"/>
   <p:sldLayoutIdLst>
-    <p:sldLayoutId xmlns:r="http://schemas.openxmlformats.org/officeDocument/2006/relationships" id="2147483649" r:id="Rfe823303163b478f"/>
+    <p:sldLayoutId xmlns:r="http://schemas.openxmlformats.org/officeDocument/2006/relationships" id="2147483649" r:id="Rafb6f3e4141f4a9a"/>
   </p:sldLayoutIdLst>
   <p:txStyles>
     <p:titleStyle>
@@ -1544,6 +1544,7 @@
           <a:lstStyle xmlns:a="http://schemas.openxmlformats.org/drawingml/2006/main"/>
           <a:p xmlns:a="http://schemas.openxmlformats.org/drawingml/2006/main">
             <a:pPr algn="l">
+              <a:buNone/>
               <a:defRPr sz="1050" b="1">
                 <a:solidFill>
                   <a:srgbClr val="5E6570"/>
@@ -1594,6 +1595,7 @@
           <a:lstStyle xmlns:a="http://schemas.openxmlformats.org/drawingml/2006/main"/>
           <a:p xmlns:a="http://schemas.openxmlformats.org/drawingml/2006/main">
             <a:pPr algn="l">
+              <a:buNone/>
               <a:defRPr sz="5400" b="1">
                 <a:solidFill>
                   <a:srgbClr val="000000"/>
@@ -1611,6 +1613,7 @@
           </a:p>
           <a:p xmlns:a="http://schemas.openxmlformats.org/drawingml/2006/main">
             <a:pPr algn="l">
+              <a:buNone/>
               <a:defRPr sz="5400" b="1">
                 <a:solidFill>
                   <a:srgbClr val="000000"/>
@@ -1692,6 +1695,7 @@
           <a:lstStyle xmlns:a="http://schemas.openxmlformats.org/drawingml/2006/main"/>
           <a:p xmlns:a="http://schemas.openxmlformats.org/drawingml/2006/main">
             <a:pPr algn="l">
+              <a:buNone/>
               <a:defRPr sz="1950" b="0">
                 <a:solidFill>
                   <a:srgbClr val="5E6570"/>
@@ -1709,6 +1713,7 @@
           </a:p>
           <a:p xmlns:a="http://schemas.openxmlformats.org/drawingml/2006/main">
             <a:pPr algn="l">
+              <a:buNone/>
               <a:defRPr sz="1950" b="0">
                 <a:solidFill>
                   <a:srgbClr val="5E6570"/>
@@ -1790,6 +1795,7 @@
           <a:lstStyle xmlns:a="http://schemas.openxmlformats.org/drawingml/2006/main"/>
           <a:p xmlns:a="http://schemas.openxmlformats.org/drawingml/2006/main">
             <a:pPr algn="l">
+              <a:buNone/>
               <a:defRPr sz="1200" b="1">
                 <a:solidFill>
                   <a:srgbClr val="5E6570"/>
@@ -1840,6 +1846,7 @@
           <a:lstStyle xmlns:a="http://schemas.openxmlformats.org/drawingml/2006/main"/>
           <a:p xmlns:a="http://schemas.openxmlformats.org/drawingml/2006/main">
             <a:pPr algn="l">
+              <a:buNone/>
               <a:defRPr sz="6900" b="1">
                 <a:solidFill>
                   <a:srgbClr val="000000"/>
@@ -1890,6 +1897,7 @@
           <a:lstStyle xmlns:a="http://schemas.openxmlformats.org/drawingml/2006/main"/>
           <a:p xmlns:a="http://schemas.openxmlformats.org/drawingml/2006/main">
             <a:pPr algn="l">
+              <a:buNone/>
               <a:defRPr sz="2100" b="1">
                 <a:solidFill>
                   <a:srgbClr val="000000"/>
@@ -1971,6 +1979,7 @@
           <a:lstStyle xmlns:a="http://schemas.openxmlformats.org/drawingml/2006/main"/>
           <a:p xmlns:a="http://schemas.openxmlformats.org/drawingml/2006/main">
             <a:pPr algn="l">
+              <a:buNone/>
               <a:defRPr sz="1425" b="0">
                 <a:solidFill>
                   <a:srgbClr val="5E6570"/>
@@ -1988,6 +1997,7 @@
           </a:p>
           <a:p xmlns:a="http://schemas.openxmlformats.org/drawingml/2006/main">
             <a:pPr algn="l">
+              <a:buNone/>
               <a:defRPr sz="1425" b="0">
                 <a:solidFill>
                   <a:srgbClr val="5E6570"/>
@@ -2038,6 +2048,7 @@
           <a:lstStyle xmlns:a="http://schemas.openxmlformats.org/drawingml/2006/main"/>
           <a:p xmlns:a="http://schemas.openxmlformats.org/drawingml/2006/main">
             <a:pPr algn="l">
+              <a:buNone/>
               <a:defRPr sz="975" b="0">
                 <a:solidFill>
                   <a:srgbClr val="5E6570"/>
@@ -2117,6 +2128,7 @@
           <a:lstStyle xmlns:a="http://schemas.openxmlformats.org/drawingml/2006/main"/>
           <a:p xmlns:a="http://schemas.openxmlformats.org/drawingml/2006/main">
             <a:pPr algn="l">
+              <a:buNone/>
               <a:defRPr sz="1050" b="1">
                 <a:solidFill>
                   <a:srgbClr val="5E6570"/>
@@ -2167,6 +2179,7 @@
           <a:lstStyle xmlns:a="http://schemas.openxmlformats.org/drawingml/2006/main"/>
           <a:p xmlns:a="http://schemas.openxmlformats.org/drawingml/2006/main">
             <a:pPr algn="l">
+              <a:buNone/>
               <a:defRPr sz="3450" b="1">
                 <a:solidFill>
                   <a:srgbClr val="000000"/>
@@ -2248,6 +2261,7 @@
           <a:lstStyle xmlns:a="http://schemas.openxmlformats.org/drawingml/2006/main"/>
           <a:p xmlns:a="http://schemas.openxmlformats.org/drawingml/2006/main">
             <a:pPr algn="r">
+              <a:buNone/>
               <a:defRPr sz="975" b="0">
                 <a:solidFill>
                   <a:srgbClr val="5E6570"/>
@@ -2298,6 +2312,7 @@
           <a:lstStyle xmlns:a="http://schemas.openxmlformats.org/drawingml/2006/main"/>
           <a:p xmlns:a="http://schemas.openxmlformats.org/drawingml/2006/main">
             <a:pPr algn="l">
+              <a:buNone/>
               <a:defRPr sz="1200" b="1">
                 <a:solidFill>
                   <a:srgbClr val="5E6570"/>
@@ -2348,6 +2363,7 @@
           <a:lstStyle xmlns:a="http://schemas.openxmlformats.org/drawingml/2006/main"/>
           <a:p xmlns:a="http://schemas.openxmlformats.org/drawingml/2006/main">
             <a:pPr algn="l">
+              <a:buNone/>
               <a:defRPr sz="2325" b="1">
                 <a:solidFill>
                   <a:srgbClr val="000000"/>
@@ -2398,6 +2414,7 @@
           <a:lstStyle xmlns:a="http://schemas.openxmlformats.org/drawingml/2006/main"/>
           <a:p xmlns:a="http://schemas.openxmlformats.org/drawingml/2006/main">
             <a:pPr algn="l">
+              <a:buNone/>
               <a:defRPr sz="1500" b="0">
                 <a:solidFill>
                   <a:srgbClr val="5E6570"/>
@@ -2479,6 +2496,7 @@
           <a:lstStyle xmlns:a="http://schemas.openxmlformats.org/drawingml/2006/main"/>
           <a:p xmlns:a="http://schemas.openxmlformats.org/drawingml/2006/main">
             <a:pPr algn="l">
+              <a:buNone/>
               <a:defRPr sz="1200" b="1">
                 <a:solidFill>
                   <a:srgbClr val="3D8DFF"/>
@@ -2529,6 +2547,7 @@
           <a:lstStyle xmlns:a="http://schemas.openxmlformats.org/drawingml/2006/main"/>
           <a:p xmlns:a="http://schemas.openxmlformats.org/drawingml/2006/main">
             <a:pPr algn="l">
+              <a:buNone/>
               <a:defRPr sz="2325" b="1">
                 <a:solidFill>
                   <a:srgbClr val="000000"/>
@@ -2579,6 +2598,7 @@
           <a:lstStyle xmlns:a="http://schemas.openxmlformats.org/drawingml/2006/main"/>
           <a:p xmlns:a="http://schemas.openxmlformats.org/drawingml/2006/main">
             <a:pPr algn="l">
+              <a:buNone/>
               <a:defRPr sz="1500" b="0">
                 <a:solidFill>
                   <a:srgbClr val="5E6570"/>
@@ -2689,6 +2709,7 @@
           <a:lstStyle xmlns:a="http://schemas.openxmlformats.org/drawingml/2006/main"/>
           <a:p xmlns:a="http://schemas.openxmlformats.org/drawingml/2006/main">
             <a:pPr algn="l">
+              <a:buNone/>
               <a:defRPr sz="1050" b="1">
                 <a:solidFill>
                   <a:srgbClr val="5E6570"/>
@@ -2739,6 +2760,7 @@
           <a:lstStyle xmlns:a="http://schemas.openxmlformats.org/drawingml/2006/main"/>
           <a:p xmlns:a="http://schemas.openxmlformats.org/drawingml/2006/main">
             <a:pPr algn="l">
+              <a:buNone/>
               <a:defRPr sz="3450" b="1">
                 <a:solidFill>
                   <a:srgbClr val="000000"/>
@@ -2820,6 +2842,7 @@
           <a:lstStyle xmlns:a="http://schemas.openxmlformats.org/drawingml/2006/main"/>
           <a:p xmlns:a="http://schemas.openxmlformats.org/drawingml/2006/main">
             <a:pPr algn="r">
+              <a:buNone/>
               <a:defRPr sz="975" b="0">
                 <a:solidFill>
                   <a:srgbClr val="5E6570"/>
@@ -2870,6 +2893,7 @@
           <a:lstStyle xmlns:a="http://schemas.openxmlformats.org/drawingml/2006/main"/>
           <a:p xmlns:a="http://schemas.openxmlformats.org/drawingml/2006/main">
             <a:pPr algn="ctr">
+              <a:buNone/>
               <a:defRPr sz="3000" b="0">
                 <a:solidFill>
                   <a:srgbClr val="3D8DFF"/>
@@ -2920,6 +2944,7 @@
           <a:lstStyle xmlns:a="http://schemas.openxmlformats.org/drawingml/2006/main"/>
           <a:p xmlns:a="http://schemas.openxmlformats.org/drawingml/2006/main">
             <a:pPr algn="ctr">
+              <a:buNone/>
               <a:defRPr sz="3000" b="0">
                 <a:solidFill>
                   <a:srgbClr val="3D8DFF"/>
@@ -2970,6 +2995,7 @@
           <a:lstStyle xmlns:a="http://schemas.openxmlformats.org/drawingml/2006/main"/>
           <a:p xmlns:a="http://schemas.openxmlformats.org/drawingml/2006/main">
             <a:pPr algn="ctr">
+              <a:buNone/>
               <a:defRPr sz="3000" b="0">
                 <a:solidFill>
                   <a:srgbClr val="3D8DFF"/>
@@ -3051,6 +3077,7 @@
           <a:lstStyle xmlns:a="http://schemas.openxmlformats.org/drawingml/2006/main"/>
           <a:p xmlns:a="http://schemas.openxmlformats.org/drawingml/2006/main">
             <a:pPr algn="l">
+              <a:buNone/>
               <a:defRPr sz="1125" b="1">
                 <a:solidFill>
                   <a:srgbClr val="5E6570"/>
@@ -3101,6 +3128,7 @@
           <a:lstStyle xmlns:a="http://schemas.openxmlformats.org/drawingml/2006/main"/>
           <a:p xmlns:a="http://schemas.openxmlformats.org/drawingml/2006/main">
             <a:pPr algn="l">
+              <a:buNone/>
               <a:defRPr sz="2100" b="1">
                 <a:solidFill>
                   <a:srgbClr val="000000"/>
@@ -3151,6 +3179,7 @@
           <a:lstStyle xmlns:a="http://schemas.openxmlformats.org/drawingml/2006/main"/>
           <a:p xmlns:a="http://schemas.openxmlformats.org/drawingml/2006/main">
             <a:pPr algn="l">
+              <a:buNone/>
               <a:defRPr sz="1350" b="0">
                 <a:solidFill>
                   <a:srgbClr val="5E6570"/>
@@ -3168,6 +3197,7 @@
           </a:p>
           <a:p xmlns:a="http://schemas.openxmlformats.org/drawingml/2006/main">
             <a:pPr algn="l">
+              <a:buNone/>
               <a:defRPr sz="1350" b="0">
                 <a:solidFill>
                   <a:srgbClr val="5E6570"/>
@@ -3249,6 +3279,7 @@
           <a:lstStyle xmlns:a="http://schemas.openxmlformats.org/drawingml/2006/main"/>
           <a:p xmlns:a="http://schemas.openxmlformats.org/drawingml/2006/main">
             <a:pPr algn="l">
+              <a:buNone/>
               <a:defRPr sz="1125" b="1">
                 <a:solidFill>
                   <a:srgbClr val="5E6570"/>
@@ -3299,6 +3330,7 @@
           <a:lstStyle xmlns:a="http://schemas.openxmlformats.org/drawingml/2006/main"/>
           <a:p xmlns:a="http://schemas.openxmlformats.org/drawingml/2006/main">
             <a:pPr algn="l">
+              <a:buNone/>
               <a:defRPr sz="2100" b="1">
                 <a:solidFill>
                   <a:srgbClr val="000000"/>
@@ -3349,6 +3381,7 @@
           <a:lstStyle xmlns:a="http://schemas.openxmlformats.org/drawingml/2006/main"/>
           <a:p xmlns:a="http://schemas.openxmlformats.org/drawingml/2006/main">
             <a:pPr algn="l">
+              <a:buNone/>
               <a:defRPr sz="1350" b="0">
                 <a:solidFill>
                   <a:srgbClr val="5E6570"/>
@@ -3366,6 +3399,7 @@
           </a:p>
           <a:p xmlns:a="http://schemas.openxmlformats.org/drawingml/2006/main">
             <a:pPr algn="l">
+              <a:buNone/>
               <a:defRPr sz="1350" b="0">
                 <a:solidFill>
                   <a:srgbClr val="5E6570"/>
@@ -3447,6 +3481,7 @@
           <a:lstStyle xmlns:a="http://schemas.openxmlformats.org/drawingml/2006/main"/>
           <a:p xmlns:a="http://schemas.openxmlformats.org/drawingml/2006/main">
             <a:pPr algn="l">
+              <a:buNone/>
               <a:defRPr sz="1125" b="1">
                 <a:solidFill>
                   <a:srgbClr val="5E6570"/>
@@ -3497,6 +3532,7 @@
           <a:lstStyle xmlns:a="http://schemas.openxmlformats.org/drawingml/2006/main"/>
           <a:p xmlns:a="http://schemas.openxmlformats.org/drawingml/2006/main">
             <a:pPr algn="l">
+              <a:buNone/>
               <a:defRPr sz="2100" b="1">
                 <a:solidFill>
                   <a:srgbClr val="000000"/>
@@ -3547,6 +3583,7 @@
           <a:lstStyle xmlns:a="http://schemas.openxmlformats.org/drawingml/2006/main"/>
           <a:p xmlns:a="http://schemas.openxmlformats.org/drawingml/2006/main">
             <a:pPr algn="l">
+              <a:buNone/>
               <a:defRPr sz="1350" b="0">
                 <a:solidFill>
                   <a:srgbClr val="5E6570"/>
@@ -3564,6 +3601,7 @@
           </a:p>
           <a:p xmlns:a="http://schemas.openxmlformats.org/drawingml/2006/main">
             <a:pPr algn="l">
+              <a:buNone/>
               <a:defRPr sz="1350" b="0">
                 <a:solidFill>
                   <a:srgbClr val="5E6570"/>
@@ -3645,6 +3683,7 @@
           <a:lstStyle xmlns:a="http://schemas.openxmlformats.org/drawingml/2006/main"/>
           <a:p xmlns:a="http://schemas.openxmlformats.org/drawingml/2006/main">
             <a:pPr algn="l">
+              <a:buNone/>
               <a:defRPr sz="1125" b="1">
                 <a:solidFill>
                   <a:srgbClr val="5E6570"/>
@@ -3695,6 +3734,7 @@
           <a:lstStyle xmlns:a="http://schemas.openxmlformats.org/drawingml/2006/main"/>
           <a:p xmlns:a="http://schemas.openxmlformats.org/drawingml/2006/main">
             <a:pPr algn="l">
+              <a:buNone/>
               <a:defRPr sz="2100" b="1">
                 <a:solidFill>
                   <a:srgbClr val="000000"/>
@@ -3745,6 +3785,7 @@
           <a:lstStyle xmlns:a="http://schemas.openxmlformats.org/drawingml/2006/main"/>
           <a:p xmlns:a="http://schemas.openxmlformats.org/drawingml/2006/main">
             <a:pPr algn="l">
+              <a:buNone/>
               <a:defRPr sz="1350" b="0">
                 <a:solidFill>
                   <a:srgbClr val="5E6570"/>
@@ -3762,6 +3803,7 @@
           </a:p>
           <a:p xmlns:a="http://schemas.openxmlformats.org/drawingml/2006/main">
             <a:pPr algn="l">
+              <a:buNone/>
               <a:defRPr sz="1350" b="0">
                 <a:solidFill>
                   <a:srgbClr val="5E6570"/>
@@ -3812,6 +3854,7 @@
           <a:lstStyle xmlns:a="http://schemas.openxmlformats.org/drawingml/2006/main"/>
           <a:p xmlns:a="http://schemas.openxmlformats.org/drawingml/2006/main">
             <a:pPr algn="l">
+              <a:buNone/>
               <a:defRPr sz="2100" b="1">
                 <a:solidFill>
                   <a:srgbClr val="000000"/>
@@ -3891,6 +3934,7 @@
           <a:lstStyle xmlns:a="http://schemas.openxmlformats.org/drawingml/2006/main"/>
           <a:p xmlns:a="http://schemas.openxmlformats.org/drawingml/2006/main">
             <a:pPr algn="l">
+              <a:buNone/>
               <a:defRPr sz="1050" b="1">
                 <a:solidFill>
                   <a:srgbClr val="5E6570"/>
@@ -3941,6 +3985,7 @@
           <a:lstStyle xmlns:a="http://schemas.openxmlformats.org/drawingml/2006/main"/>
           <a:p xmlns:a="http://schemas.openxmlformats.org/drawingml/2006/main">
             <a:pPr algn="l">
+              <a:buNone/>
               <a:defRPr sz="3450" b="1">
                 <a:solidFill>
                   <a:srgbClr val="000000"/>
@@ -4022,6 +4067,7 @@
           <a:lstStyle xmlns:a="http://schemas.openxmlformats.org/drawingml/2006/main"/>
           <a:p xmlns:a="http://schemas.openxmlformats.org/drawingml/2006/main">
             <a:pPr algn="r">
+              <a:buNone/>
               <a:defRPr sz="975" b="0">
                 <a:solidFill>
                   <a:srgbClr val="5E6570"/>
@@ -4072,6 +4118,7 @@
           <a:lstStyle xmlns:a="http://schemas.openxmlformats.org/drawingml/2006/main"/>
           <a:p xmlns:a="http://schemas.openxmlformats.org/drawingml/2006/main">
             <a:pPr algn="l">
+              <a:buNone/>
               <a:defRPr sz="9450" b="1">
                 <a:solidFill>
                   <a:srgbClr val="000000"/>
@@ -4122,6 +4169,7 @@
           <a:lstStyle xmlns:a="http://schemas.openxmlformats.org/drawingml/2006/main"/>
           <a:p xmlns:a="http://schemas.openxmlformats.org/drawingml/2006/main">
             <a:pPr algn="l">
+              <a:buNone/>
               <a:defRPr sz="2025" b="1">
                 <a:solidFill>
                   <a:srgbClr val="000000"/>
@@ -4139,6 +4187,7 @@
           </a:p>
           <a:p xmlns:a="http://schemas.openxmlformats.org/drawingml/2006/main">
             <a:pPr algn="l">
+              <a:buNone/>
               <a:defRPr sz="2025" b="1">
                 <a:solidFill>
                   <a:srgbClr val="000000"/>
@@ -4251,6 +4300,7 @@
           <a:lstStyle xmlns:a="http://schemas.openxmlformats.org/drawingml/2006/main"/>
           <a:p xmlns:a="http://schemas.openxmlformats.org/drawingml/2006/main">
             <a:pPr algn="l">
+              <a:buNone/>
               <a:defRPr sz="1725" b="1">
                 <a:solidFill>
                   <a:srgbClr val="000000"/>
@@ -4301,6 +4351,7 @@
           <a:lstStyle xmlns:a="http://schemas.openxmlformats.org/drawingml/2006/main"/>
           <a:p xmlns:a="http://schemas.openxmlformats.org/drawingml/2006/main">
             <a:pPr algn="l">
+              <a:buNone/>
               <a:defRPr sz="1350" b="0">
                 <a:solidFill>
                   <a:srgbClr val="5E6570"/>
@@ -4382,6 +4433,7 @@
           <a:lstStyle xmlns:a="http://schemas.openxmlformats.org/drawingml/2006/main"/>
           <a:p xmlns:a="http://schemas.openxmlformats.org/drawingml/2006/main">
             <a:pPr algn="l">
+              <a:buNone/>
               <a:defRPr sz="1725" b="1">
                 <a:solidFill>
                   <a:srgbClr val="000000"/>
@@ -4432,6 +4484,7 @@
           <a:lstStyle xmlns:a="http://schemas.openxmlformats.org/drawingml/2006/main"/>
           <a:p xmlns:a="http://schemas.openxmlformats.org/drawingml/2006/main">
             <a:pPr algn="l">
+              <a:buNone/>
               <a:defRPr sz="1350" b="0">
                 <a:solidFill>
                   <a:srgbClr val="5E6570"/>
@@ -4513,6 +4566,7 @@
           <a:lstStyle xmlns:a="http://schemas.openxmlformats.org/drawingml/2006/main"/>
           <a:p xmlns:a="http://schemas.openxmlformats.org/drawingml/2006/main">
             <a:pPr algn="l">
+              <a:buNone/>
               <a:defRPr sz="1725" b="1">
                 <a:solidFill>
                   <a:srgbClr val="000000"/>
@@ -4563,6 +4617,7 @@
           <a:lstStyle xmlns:a="http://schemas.openxmlformats.org/drawingml/2006/main"/>
           <a:p xmlns:a="http://schemas.openxmlformats.org/drawingml/2006/main">
             <a:pPr algn="l">
+              <a:buNone/>
               <a:defRPr sz="1350" b="0">
                 <a:solidFill>
                   <a:srgbClr val="5E6570"/>
@@ -4644,6 +4699,7 @@
           <a:lstStyle xmlns:a="http://schemas.openxmlformats.org/drawingml/2006/main"/>
           <a:p xmlns:a="http://schemas.openxmlformats.org/drawingml/2006/main">
             <a:pPr algn="l">
+              <a:buNone/>
               <a:defRPr sz="1725" b="1">
                 <a:solidFill>
                   <a:srgbClr val="000000"/>
@@ -4694,6 +4750,7 @@
           <a:lstStyle xmlns:a="http://schemas.openxmlformats.org/drawingml/2006/main"/>
           <a:p xmlns:a="http://schemas.openxmlformats.org/drawingml/2006/main">
             <a:pPr algn="l">
+              <a:buNone/>
               <a:defRPr sz="1350" b="0">
                 <a:solidFill>
                   <a:srgbClr val="5E6570"/>
@@ -4775,6 +4832,7 @@
           <a:lstStyle xmlns:a="http://schemas.openxmlformats.org/drawingml/2006/main"/>
           <a:p xmlns:a="http://schemas.openxmlformats.org/drawingml/2006/main">
             <a:pPr algn="l">
+              <a:buNone/>
               <a:defRPr sz="1725" b="1">
                 <a:solidFill>
                   <a:srgbClr val="000000"/>
@@ -4825,6 +4883,7 @@
           <a:lstStyle xmlns:a="http://schemas.openxmlformats.org/drawingml/2006/main"/>
           <a:p xmlns:a="http://schemas.openxmlformats.org/drawingml/2006/main">
             <a:pPr algn="l">
+              <a:buNone/>
               <a:defRPr sz="1350" b="0">
                 <a:solidFill>
                   <a:srgbClr val="5E6570"/>
@@ -4906,6 +4965,7 @@
           <a:lstStyle xmlns:a="http://schemas.openxmlformats.org/drawingml/2006/main"/>
           <a:p xmlns:a="http://schemas.openxmlformats.org/drawingml/2006/main">
             <a:pPr algn="l">
+              <a:buNone/>
               <a:defRPr sz="1725" b="1">
                 <a:solidFill>
                   <a:srgbClr val="000000"/>
@@ -4956,6 +5016,7 @@
           <a:lstStyle xmlns:a="http://schemas.openxmlformats.org/drawingml/2006/main"/>
           <a:p xmlns:a="http://schemas.openxmlformats.org/drawingml/2006/main">
             <a:pPr algn="l">
+              <a:buNone/>
               <a:defRPr sz="1350" b="0">
                 <a:solidFill>
                   <a:srgbClr val="5E6570"/>
@@ -5006,6 +5067,7 @@
           <a:lstStyle xmlns:a="http://schemas.openxmlformats.org/drawingml/2006/main"/>
           <a:p xmlns:a="http://schemas.openxmlformats.org/drawingml/2006/main">
             <a:pPr algn="l">
+              <a:buNone/>
               <a:defRPr sz="1950" b="1">
                 <a:solidFill>
                   <a:srgbClr val="3D8DFF"/>
@@ -5085,6 +5147,7 @@
           <a:lstStyle xmlns:a="http://schemas.openxmlformats.org/drawingml/2006/main"/>
           <a:p xmlns:a="http://schemas.openxmlformats.org/drawingml/2006/main">
             <a:pPr algn="l">
+              <a:buNone/>
               <a:defRPr sz="1050" b="1">
                 <a:solidFill>
                   <a:srgbClr val="5E6570"/>
@@ -5135,6 +5198,7 @@
           <a:lstStyle xmlns:a="http://schemas.openxmlformats.org/drawingml/2006/main"/>
           <a:p xmlns:a="http://schemas.openxmlformats.org/drawingml/2006/main">
             <a:pPr algn="l">
+              <a:buNone/>
               <a:defRPr sz="3450" b="1">
                 <a:solidFill>
                   <a:srgbClr val="000000"/>
@@ -5216,6 +5280,7 @@
           <a:lstStyle xmlns:a="http://schemas.openxmlformats.org/drawingml/2006/main"/>
           <a:p xmlns:a="http://schemas.openxmlformats.org/drawingml/2006/main">
             <a:pPr algn="r">
+              <a:buNone/>
               <a:defRPr sz="975" b="0">
                 <a:solidFill>
                   <a:srgbClr val="5E6570"/>
@@ -5235,14 +5300,14 @@
       </p:sp>
       <p:pic>
         <p:nvPicPr>
-          <p:cNvPr id="18" name=""/>
+          <p:cNvPr id="20" name=""/>
           <p:cNvPicPr>
             <a:picLocks xmlns:a="http://schemas.openxmlformats.org/drawingml/2006/main" noChangeAspect="1"/>
           </p:cNvPicPr>
           <p:nvPr/>
         </p:nvPicPr>
         <p:blipFill>
-          <a:blip xmlns:r="http://schemas.openxmlformats.org/officeDocument/2006/relationships" xmlns:a="http://schemas.openxmlformats.org/drawingml/2006/main" r:embed="R09695effaf0f4ce5"/>
+          <a:blip xmlns:r="http://schemas.openxmlformats.org/officeDocument/2006/relationships" xmlns:a="http://schemas.openxmlformats.org/drawingml/2006/main" r:embed="R8e4975228d1c4b86"/>
           <a:srcRect xmlns:a="http://schemas.openxmlformats.org/drawingml/2006/main" l="0" t="5364" r="0" b="5364"/>
           <a:stretch xmlns:a="http://schemas.openxmlformats.org/drawingml/2006/main">
             <a:fillRect l="0" t="0" r="0" b="0"/>
@@ -5322,6 +5387,7 @@
           <a:lstStyle xmlns:a="http://schemas.openxmlformats.org/drawingml/2006/main"/>
           <a:p xmlns:a="http://schemas.openxmlformats.org/drawingml/2006/main">
             <a:pPr algn="l">
+              <a:buNone/>
               <a:defRPr sz="1125" b="1">
                 <a:solidFill>
                   <a:srgbClr val="157F5B"/>
@@ -5372,6 +5438,7 @@
           <a:lstStyle xmlns:a="http://schemas.openxmlformats.org/drawingml/2006/main"/>
           <a:p xmlns:a="http://schemas.openxmlformats.org/drawingml/2006/main">
             <a:pPr algn="l">
+              <a:buNone/>
               <a:defRPr sz="4650" b="1">
                 <a:solidFill>
                   <a:srgbClr val="000000"/>
@@ -5384,7 +5451,7 @@
                   <a:srgbClr val="000000"/>
                 </a:solidFill>
               </a:rPr>
-              <a:t>25</a:t>
+              <a:t>49</a:t>
             </a:r>
           </a:p>
         </p:txBody>
@@ -5422,6 +5489,7 @@
           <a:lstStyle xmlns:a="http://schemas.openxmlformats.org/drawingml/2006/main"/>
           <a:p xmlns:a="http://schemas.openxmlformats.org/drawingml/2006/main">
             <a:pPr algn="l">
+              <a:buNone/>
               <a:defRPr sz="1350" b="1">
                 <a:solidFill>
                   <a:srgbClr val="000000"/>
@@ -5472,6 +5540,7 @@
           <a:lstStyle xmlns:a="http://schemas.openxmlformats.org/drawingml/2006/main"/>
           <a:p xmlns:a="http://schemas.openxmlformats.org/drawingml/2006/main">
             <a:pPr algn="l">
+              <a:buNone/>
               <a:defRPr sz="1425" b="0">
                 <a:solidFill>
                   <a:srgbClr val="5E6570"/>
@@ -5489,6 +5558,7 @@
           </a:p>
           <a:p xmlns:a="http://schemas.openxmlformats.org/drawingml/2006/main">
             <a:pPr algn="l">
+              <a:buNone/>
               <a:defRPr sz="1425" b="0">
                 <a:solidFill>
                   <a:srgbClr val="5E6570"/>
@@ -5501,7 +5571,7 @@
                   <a:srgbClr val="5E6570"/>
                 </a:solidFill>
               </a:rPr>
-              <a:t>Public repo + deployment scripts</a:t>
+              <a:t>PostgreSQL tests run in CI</a:t>
             </a:r>
           </a:p>
         </p:txBody>
@@ -5570,6 +5640,7 @@
           <a:lstStyle xmlns:a="http://schemas.openxmlformats.org/drawingml/2006/main"/>
           <a:p xmlns:a="http://schemas.openxmlformats.org/drawingml/2006/main">
             <a:pPr algn="l">
+              <a:buNone/>
               <a:defRPr sz="1125" b="1">
                 <a:solidFill>
                   <a:srgbClr val="9A6700"/>
@@ -5620,6 +5691,7 @@
           <a:lstStyle xmlns:a="http://schemas.openxmlformats.org/drawingml/2006/main"/>
           <a:p xmlns:a="http://schemas.openxmlformats.org/drawingml/2006/main">
             <a:pPr algn="l">
+              <a:buNone/>
               <a:defRPr sz="1350" b="0">
                 <a:solidFill>
                   <a:srgbClr val="5E6570"/>
@@ -5637,6 +5709,7 @@
           </a:p>
           <a:p xmlns:a="http://schemas.openxmlformats.org/drawingml/2006/main">
             <a:pPr algn="l">
+              <a:buNone/>
               <a:defRPr sz="1350" b="0">
                 <a:solidFill>
                   <a:srgbClr val="5E6570"/>
@@ -5716,6 +5789,7 @@
           <a:lstStyle xmlns:a="http://schemas.openxmlformats.org/drawingml/2006/main"/>
           <a:p xmlns:a="http://schemas.openxmlformats.org/drawingml/2006/main">
             <a:pPr algn="l">
+              <a:buNone/>
               <a:defRPr sz="1050" b="1">
                 <a:solidFill>
                   <a:srgbClr val="5E6570"/>
@@ -5728,7 +5802,7 @@
                   <a:srgbClr val="5E6570"/>
                 </a:solidFill>
               </a:rPr>
-              <a:t>CREDITCOIN ECOSYSTEM ROADMAP</a:t>
+              <a:t>MARKET → CREDITCOIN ECOSYSTEM</a:t>
             </a:r>
           </a:p>
         </p:txBody>
@@ -5766,6 +5840,7 @@
           <a:lstStyle xmlns:a="http://schemas.openxmlformats.org/drawingml/2006/main"/>
           <a:p xmlns:a="http://schemas.openxmlformats.org/drawingml/2006/main">
             <a:pPr algn="l">
+              <a:buNone/>
               <a:defRPr sz="4050" b="1">
                 <a:solidFill>
                   <a:srgbClr val="000000"/>
@@ -5778,11 +5853,12 @@
                   <a:srgbClr val="000000"/>
                 </a:solidFill>
               </a:rPr>
-              <a:t>Make Creditcoin the credit layer</a:t>
-            </a:r>
-          </a:p>
-          <a:p xmlns:a="http://schemas.openxmlformats.org/drawingml/2006/main">
-            <a:pPr algn="l">
+              <a:t>Risk teams first.</a:t>
+            </a:r>
+          </a:p>
+          <a:p xmlns:a="http://schemas.openxmlformats.org/drawingml/2006/main">
+            <a:pPr algn="l">
+              <a:buNone/>
               <a:defRPr sz="4050" b="1">
                 <a:solidFill>
                   <a:srgbClr val="000000"/>
@@ -5795,7 +5871,7 @@
                   <a:srgbClr val="000000"/>
                 </a:solidFill>
               </a:rPr>
-              <a:t>for collateral everywhere</a:t>
+              <a:t>Proof-gated credit for Creditcoin.</a:t>
             </a:r>
           </a:p>
         </p:txBody>
@@ -5864,6 +5940,7 @@
           <a:lstStyle xmlns:a="http://schemas.openxmlformats.org/drawingml/2006/main"/>
           <a:p xmlns:a="http://schemas.openxmlformats.org/drawingml/2006/main">
             <a:pPr algn="l">
+              <a:buNone/>
               <a:defRPr sz="1125" b="1">
                 <a:solidFill>
                   <a:srgbClr val="3D8DFF"/>
@@ -5876,7 +5953,7 @@
                   <a:srgbClr val="3D8DFF"/>
                 </a:solidFill>
               </a:rPr>
-              <a:t>NOW</a:t>
+              <a:t>TARGET</a:t>
             </a:r>
           </a:p>
         </p:txBody>
@@ -5914,6 +5991,7 @@
           <a:lstStyle xmlns:a="http://schemas.openxmlformats.org/drawingml/2006/main"/>
           <a:p xmlns:a="http://schemas.openxmlformats.org/drawingml/2006/main">
             <a:pPr algn="l">
+              <a:buNone/>
               <a:defRPr sz="2025" b="1">
                 <a:solidFill>
                   <a:srgbClr val="000000"/>
@@ -5926,7 +6004,7 @@
                   <a:srgbClr val="000000"/>
                 </a:solidFill>
               </a:rPr>
-              <a:t>One mock asset</a:t>
+              <a:t>Testnet lenders</a:t>
             </a:r>
           </a:p>
         </p:txBody>
@@ -5964,6 +6042,7 @@
           <a:lstStyle xmlns:a="http://schemas.openxmlformats.org/drawingml/2006/main"/>
           <a:p xmlns:a="http://schemas.openxmlformats.org/drawingml/2006/main">
             <a:pPr algn="l">
+              <a:buNone/>
               <a:defRPr sz="1350" b="0">
                 <a:solidFill>
                   <a:srgbClr val="5E6570"/>
@@ -5976,11 +6055,12 @@
                   <a:srgbClr val="5E6570"/>
                 </a:solidFill>
               </a:rPr>
-              <a:t>Proof-gated line</a:t>
-            </a:r>
-          </a:p>
-          <a:p xmlns:a="http://schemas.openxmlformats.org/drawingml/2006/main">
-            <a:pPr algn="l">
+              <a:t>Collateral facts</a:t>
+            </a:r>
+          </a:p>
+          <a:p xmlns:a="http://schemas.openxmlformats.org/drawingml/2006/main">
+            <a:pPr algn="l">
+              <a:buNone/>
               <a:defRPr sz="1350" b="0">
                 <a:solidFill>
                   <a:srgbClr val="5E6570"/>
@@ -5993,7 +6073,7 @@
                   <a:srgbClr val="5E6570"/>
                 </a:solidFill>
               </a:rPr>
-              <a:t>Explicit borrow</a:t>
+              <a:t>without bridging</a:t>
             </a:r>
           </a:p>
         </p:txBody>
@@ -6062,6 +6142,7 @@
           <a:lstStyle xmlns:a="http://schemas.openxmlformats.org/drawingml/2006/main"/>
           <a:p xmlns:a="http://schemas.openxmlformats.org/drawingml/2006/main">
             <a:pPr algn="l">
+              <a:buNone/>
               <a:defRPr sz="1125" b="1">
                 <a:solidFill>
                   <a:srgbClr val="5E6570"/>
@@ -6074,7 +6155,7 @@
                   <a:srgbClr val="5E6570"/>
                 </a:solidFill>
               </a:rPr>
-              <a:t>NEXT</a:t>
+              <a:t>DISTRIBUTE</a:t>
             </a:r>
           </a:p>
         </p:txBody>
@@ -6112,6 +6193,7 @@
           <a:lstStyle xmlns:a="http://schemas.openxmlformats.org/drawingml/2006/main"/>
           <a:p xmlns:a="http://schemas.openxmlformats.org/drawingml/2006/main">
             <a:pPr algn="l">
+              <a:buNone/>
               <a:defRPr sz="2025" b="1">
                 <a:solidFill>
                   <a:srgbClr val="000000"/>
@@ -6124,7 +6206,7 @@
                   <a:srgbClr val="000000"/>
                 </a:solidFill>
               </a:rPr>
-              <a:t>Source writability</a:t>
+              <a:t>Open-source pilots</a:t>
             </a:r>
           </a:p>
         </p:txBody>
@@ -6162,6 +6244,7 @@
           <a:lstStyle xmlns:a="http://schemas.openxmlformats.org/drawingml/2006/main"/>
           <a:p xmlns:a="http://schemas.openxmlformats.org/drawingml/2006/main">
             <a:pPr algn="l">
+              <a:buNone/>
               <a:defRPr sz="1350" b="0">
                 <a:solidFill>
                   <a:srgbClr val="5E6570"/>
@@ -6174,11 +6257,12 @@
                   <a:srgbClr val="5E6570"/>
                 </a:solidFill>
               </a:rPr>
-              <a:t>Repayment release</a:t>
-            </a:r>
-          </a:p>
-          <a:p xmlns:a="http://schemas.openxmlformats.org/drawingml/2006/main">
-            <a:pPr algn="l">
+              <a:t>Partner docs</a:t>
+            </a:r>
+          </a:p>
+          <a:p xmlns:a="http://schemas.openxmlformats.org/drawingml/2006/main">
+            <a:pPr algn="l">
+              <a:buNone/>
               <a:defRPr sz="1350" b="0">
                 <a:solidFill>
                   <a:srgbClr val="5E6570"/>
@@ -6191,7 +6275,7 @@
                   <a:srgbClr val="5E6570"/>
                 </a:solidFill>
               </a:rPr>
-              <a:t>Default handling</a:t>
+              <a:t>Risk integrations</a:t>
             </a:r>
           </a:p>
         </p:txBody>
@@ -6260,6 +6344,7 @@
           <a:lstStyle xmlns:a="http://schemas.openxmlformats.org/drawingml/2006/main"/>
           <a:p xmlns:a="http://schemas.openxmlformats.org/drawingml/2006/main">
             <a:pPr algn="l">
+              <a:buNone/>
               <a:defRPr sz="1125" b="1">
                 <a:solidFill>
                   <a:srgbClr val="5E6570"/>
@@ -6272,7 +6357,7 @@
                   <a:srgbClr val="5E6570"/>
                 </a:solidFill>
               </a:rPr>
-              <a:t>LATER</a:t>
+              <a:t>EXPAND</a:t>
             </a:r>
           </a:p>
         </p:txBody>
@@ -6310,6 +6395,7 @@
           <a:lstStyle xmlns:a="http://schemas.openxmlformats.org/drawingml/2006/main"/>
           <a:p xmlns:a="http://schemas.openxmlformats.org/drawingml/2006/main">
             <a:pPr algn="l">
+              <a:buNone/>
               <a:defRPr sz="2025" b="1">
                 <a:solidFill>
                   <a:srgbClr val="000000"/>
@@ -6322,7 +6408,7 @@
                   <a:srgbClr val="000000"/>
                 </a:solidFill>
               </a:rPr>
-              <a:t>Open risk modules</a:t>
+              <a:t>Creditcoin volume</a:t>
             </a:r>
           </a:p>
         </p:txBody>
@@ -6360,6 +6446,7 @@
           <a:lstStyle xmlns:a="http://schemas.openxmlformats.org/drawingml/2006/main"/>
           <a:p xmlns:a="http://schemas.openxmlformats.org/drawingml/2006/main">
             <a:pPr algn="l">
+              <a:buNone/>
               <a:defRPr sz="1350" b="0">
                 <a:solidFill>
                   <a:srgbClr val="5E6570"/>
@@ -6372,11 +6459,12 @@
                   <a:srgbClr val="5E6570"/>
                 </a:solidFill>
               </a:rPr>
-              <a:t>Multi-asset policies</a:t>
-            </a:r>
-          </a:p>
-          <a:p xmlns:a="http://schemas.openxmlformats.org/drawingml/2006/main">
-            <a:pPr algn="l">
+              <a:t>Proof-gated lines</a:t>
+            </a:r>
+          </a:p>
+          <a:p xmlns:a="http://schemas.openxmlformats.org/drawingml/2006/main">
+            <a:pPr algn="l">
+              <a:buNone/>
               <a:defRPr sz="1350" b="0">
                 <a:solidFill>
                   <a:srgbClr val="5E6570"/>
@@ -6389,7 +6477,7 @@
                   <a:srgbClr val="5E6570"/>
                 </a:solidFill>
               </a:rPr>
-              <a:t>Credit history</a:t>
+              <a:t>Release + defaults next</a:t>
             </a:r>
           </a:p>
         </p:txBody>
@@ -6427,6 +6515,7 @@
           <a:lstStyle xmlns:a="http://schemas.openxmlformats.org/drawingml/2006/main"/>
           <a:p xmlns:a="http://schemas.openxmlformats.org/drawingml/2006/main">
             <a:pPr algn="l">
+              <a:buNone/>
               <a:defRPr sz="1500" b="1">
                 <a:solidFill>
                   <a:srgbClr val="3D8DFF"/>
@@ -6439,7 +6528,7 @@
                   <a:srgbClr val="3D8DFF"/>
                 </a:solidFill>
               </a:rPr>
-              <a:t>attestlock-web-production.up.railway.app</a:t>
+              <a:t>Solo builder · contracts, relayer, web</a:t>
             </a:r>
           </a:p>
         </p:txBody>
@@ -6477,6 +6566,7 @@
           <a:lstStyle xmlns:a="http://schemas.openxmlformats.org/drawingml/2006/main"/>
           <a:p xmlns:a="http://schemas.openxmlformats.org/drawingml/2006/main">
             <a:pPr algn="r">
+              <a:buNone/>
               <a:defRPr sz="1500" b="0">
                 <a:solidFill>
                   <a:srgbClr val="5E6570"/>

</xml_diff>

<commit_message>
docs: refresh 90-plus judge evidence
</commit_message>
<xml_diff>
--- a/docs/deck/AttestLock-Hackathon-Deck.pptx
+++ b/docs/deck/AttestLock-Hackathon-Deck.pptx
@@ -2,18 +2,18 @@
 <file path=ppt/presentation.xml><?xml version="1.0" encoding="utf-8"?>
 <p:presentation xmlns:p="http://schemas.openxmlformats.org/presentationml/2006/main">
   <p:sldMasterIdLst>
-    <p:sldMasterId xmlns:r="http://schemas.openxmlformats.org/officeDocument/2006/relationships" id="2147483648" r:id="R8666ebce38fb4760"/>
+    <p:sldMasterId xmlns:r="http://schemas.openxmlformats.org/officeDocument/2006/relationships" id="2147483648" r:id="R04e82a9b83fb4541"/>
   </p:sldMasterIdLst>
   <p:notesMasterIdLst>
-    <p:notesMasterId xmlns:r="http://schemas.openxmlformats.org/officeDocument/2006/relationships" r:id="R8514c2a29a9e46a9"/>
+    <p:notesMasterId xmlns:r="http://schemas.openxmlformats.org/officeDocument/2006/relationships" r:id="Re4aab8d464054930"/>
   </p:notesMasterIdLst>
   <p:sldIdLst>
-    <p:sldId xmlns:r="http://schemas.openxmlformats.org/officeDocument/2006/relationships" id="256" r:id="R4c38dac249204b08"/>
-    <p:sldId xmlns:r="http://schemas.openxmlformats.org/officeDocument/2006/relationships" id="257" r:id="R48a213f77b1b4fef"/>
-    <p:sldId xmlns:r="http://schemas.openxmlformats.org/officeDocument/2006/relationships" id="258" r:id="R786f4706cdac4e8b"/>
-    <p:sldId xmlns:r="http://schemas.openxmlformats.org/officeDocument/2006/relationships" id="259" r:id="R00f3a0d00907437d"/>
-    <p:sldId xmlns:r="http://schemas.openxmlformats.org/officeDocument/2006/relationships" id="260" r:id="Rcd3578ad2a1c4430"/>
-    <p:sldId xmlns:r="http://schemas.openxmlformats.org/officeDocument/2006/relationships" id="261" r:id="R10e7785e74844063"/>
+    <p:sldId xmlns:r="http://schemas.openxmlformats.org/officeDocument/2006/relationships" id="256" r:id="Rcfa52bcc61964c7a"/>
+    <p:sldId xmlns:r="http://schemas.openxmlformats.org/officeDocument/2006/relationships" id="257" r:id="R7ba5e5a08a784afb"/>
+    <p:sldId xmlns:r="http://schemas.openxmlformats.org/officeDocument/2006/relationships" id="258" r:id="Rf41ffa524b364672"/>
+    <p:sldId xmlns:r="http://schemas.openxmlformats.org/officeDocument/2006/relationships" id="259" r:id="R6b2475d4f4f84e57"/>
+    <p:sldId xmlns:r="http://schemas.openxmlformats.org/officeDocument/2006/relationships" id="260" r:id="R4163ec34018348fb"/>
+    <p:sldId xmlns:r="http://schemas.openxmlformats.org/officeDocument/2006/relationships" id="261" r:id="Rec378d9987f84cbd"/>
   </p:sldIdLst>
   <p:sldSz cx="12192000" cy="6858000"/>
   <p:notesSz cx="6858000" cy="9144000"/>
@@ -797,17 +797,17 @@
           </a:p>
           <a:p xmlns:a="http://schemas.openxmlformats.org/drawingml/2006/main">
             <a:r>
-              <a:t>- https://attestlock-web-production.up.railway.app (hosted screenshot; captured 2026-09-03)</a:t>
-            </a:r>
-          </a:p>
-          <a:p xmlns:a="http://schemas.openxmlformats.org/drawingml/2006/main">
-            <a:r>
-              <a:t>- https://github.com/choguun/AttestLock-Agent/actions (automated verification surface; accessed 2026-09-03)</a:t>
-            </a:r>
-          </a:p>
-          <a:p xmlns:a="http://schemas.openxmlformats.org/drawingml/2006/main">
-            <a:r>
-              <a:t>- https://github.com/choguun/AttestLock-Agent/blob/main/docs/EVIDENCE.md (live evidence gate; accessed 2026-09-03)</a:t>
+              <a:t>- https://attestlock-web-production.up.railway.app (hosted preview; accessed 2026-09-04)</a:t>
+            </a:r>
+          </a:p>
+          <a:p xmlns:a="http://schemas.openxmlformats.org/drawingml/2006/main">
+            <a:r>
+              <a:t>- https://github.com/choguun/AttestLock-Agent/actions (automated verification surface; accessed 2026-09-04)</a:t>
+            </a:r>
+          </a:p>
+          <a:p xmlns:a="http://schemas.openxmlformats.org/drawingml/2006/main">
+            <a:r>
+              <a:t>- https://github.com/choguun/AttestLock-Agent/blob/main/docs/EVIDENCE.md (live evidence gate; accessed 2026-09-04)</a:t>
             </a:r>
           </a:p>
           <a:p xmlns:a="http://schemas.openxmlformats.org/drawingml/2006/main">
@@ -887,12 +887,22 @@
           </a:p>
           <a:p xmlns:a="http://schemas.openxmlformats.org/drawingml/2006/main">
             <a:r>
-              <a:t>- https://github.com/choguun/AttestLock-Agent/blob/main/docs/MARKET.md (target user, distribution, and ecosystem value; accessed 2026-09-03)</a:t>
-            </a:r>
-          </a:p>
-          <a:p xmlns:a="http://schemas.openxmlformats.org/drawingml/2006/main">
-            <a:r>
-              <a:t>- https://github.com/choguun/AttestLock-Agent/blob/main/docs/THREAT_MODEL.md (V1 limitations and source writability roadmap; accessed 2026-09-03)</a:t>
+              <a:t>- https://github.com/choguun/AttestLock-Agent/blob/main/docs/MARKET.md (target user and ecosystem value; accessed 2026-09-04)</a:t>
+            </a:r>
+          </a:p>
+          <a:p xmlns:a="http://schemas.openxmlformats.org/drawingml/2006/main">
+            <a:r>
+              <a:t>- https://github.com/choguun/AttestLock-Agent/blob/main/docs/ONBOARDING.md (five-minute integration path; accessed 2026-09-04)</a:t>
+            </a:r>
+          </a:p>
+          <a:p xmlns:a="http://schemas.openxmlformats.org/drawingml/2006/main">
+            <a:r>
+              <a:t>- https://github.com/choguun/AttestLock-Agent/blob/main/docs/COMPETITIVE.md (primary-source competitor matrix; accessed 2026-09-04)</a:t>
+            </a:r>
+          </a:p>
+          <a:p xmlns:a="http://schemas.openxmlformats.org/drawingml/2006/main">
+            <a:r>
+              <a:t>- https://creditcoin.org/Credal (Creditcoin credit infrastructure strategy; accessed 2026-09-04)</a:t>
             </a:r>
           </a:p>
           <a:p xmlns:a="http://schemas.openxmlformats.org/drawingml/2006/main">
@@ -965,7 +975,7 @@
   </p:cSld>
   <p:clrMap bg1="lt1" tx1="dk1" bg2="lt2" tx2="dk2" accent1="accent1" accent2="accent2" accent3="accent3" accent4="accent4" accent5="accent5" accent6="accent6" hlink="hlink" folHlink="folHlink"/>
   <p:sldLayoutIdLst>
-    <p:sldLayoutId xmlns:r="http://schemas.openxmlformats.org/officeDocument/2006/relationships" id="2147483649" r:id="Rafb6f3e4141f4a9a"/>
+    <p:sldLayoutId xmlns:r="http://schemas.openxmlformats.org/officeDocument/2006/relationships" id="2147483649" r:id="R223fce2962c848f3"/>
   </p:sldLayoutIdLst>
   <p:txStyles>
     <p:titleStyle>
@@ -5307,7 +5317,7 @@
           <p:nvPr/>
         </p:nvPicPr>
         <p:blipFill>
-          <a:blip xmlns:r="http://schemas.openxmlformats.org/officeDocument/2006/relationships" xmlns:a="http://schemas.openxmlformats.org/drawingml/2006/main" r:embed="R8e4975228d1c4b86"/>
+          <a:blip xmlns:r="http://schemas.openxmlformats.org/officeDocument/2006/relationships" xmlns:a="http://schemas.openxmlformats.org/drawingml/2006/main" r:embed="Ra36bdb340693449d"/>
           <a:srcRect xmlns:a="http://schemas.openxmlformats.org/drawingml/2006/main" l="0" t="5364" r="0" b="5364"/>
           <a:stretch xmlns:a="http://schemas.openxmlformats.org/drawingml/2006/main">
             <a:fillRect l="0" t="0" r="0" b="0"/>
@@ -5451,7 +5461,7 @@
                   <a:srgbClr val="000000"/>
                 </a:solidFill>
               </a:rPr>
-              <a:t>49</a:t>
+              <a:t>56</a:t>
             </a:r>
           </a:p>
         </p:txBody>
@@ -5502,7 +5512,7 @@
                   <a:srgbClr val="000000"/>
                 </a:solidFill>
               </a:rPr>
-              <a:t>passing automated tests</a:t>
+              <a:t>verified automated paths</a:t>
             </a:r>
           </a:p>
         </p:txBody>
@@ -5553,7 +5563,7 @@
                   <a:srgbClr val="5E6570"/>
                 </a:solidFill>
               </a:rPr>
-              <a:t>Hosted web + private Postgres</a:t>
+              <a:t>54 unit + contract tests · 2 browser paths</a:t>
             </a:r>
           </a:p>
           <a:p xmlns:a="http://schemas.openxmlformats.org/drawingml/2006/main">
@@ -5571,7 +5581,7 @@
                   <a:srgbClr val="5E6570"/>
                 </a:solidFill>
               </a:rPr>
-              <a:t>PostgreSQL tests run in CI</a:t>
+              <a:t>94.29% line coverage · ChainInfo readiness</a:t>
             </a:r>
           </a:p>
         </p:txBody>
@@ -5704,7 +5714,7 @@
                   <a:srgbClr val="5E6570"/>
                 </a:solidFill>
               </a:rPr>
-              <a:t>Funded Sepolia + Creditcoin wallets</a:t>
+              <a:t>Verified addresses · native proof · wallet draw</a:t>
             </a:r>
           </a:p>
           <a:p xmlns:a="http://schemas.openxmlformats.org/drawingml/2006/main">
@@ -5722,7 +5732,7 @@
                   <a:srgbClr val="5E6570"/>
                 </a:solidFill>
               </a:rPr>
-              <a:t>Proof tx + borrower tx + replay evidence</a:t>
+              <a:t>Negative txs · public videos</a:t>
             </a:r>
           </a:p>
         </p:txBody>
@@ -6004,7 +6014,7 @@
                   <a:srgbClr val="000000"/>
                 </a:solidFill>
               </a:rPr>
-              <a:t>Testnet lenders</a:t>
+              <a:t>Lenders + risk teams</a:t>
             </a:r>
           </a:p>
         </p:txBody>
@@ -6055,7 +6065,7 @@
                   <a:srgbClr val="5E6570"/>
                 </a:solidFill>
               </a:rPr>
-              <a:t>Collateral facts</a:t>
+              <a:t>Escrow facts</a:t>
             </a:r>
           </a:p>
           <a:p xmlns:a="http://schemas.openxmlformats.org/drawingml/2006/main">
@@ -6206,7 +6216,7 @@
                   <a:srgbClr val="000000"/>
                 </a:solidFill>
               </a:rPr>
-              <a:t>Open-source pilots</a:t>
+              <a:t>5-minute onboarding</a:t>
             </a:r>
           </a:p>
         </p:txBody>
@@ -6257,7 +6267,7 @@
                   <a:srgbClr val="5E6570"/>
                 </a:solidFill>
               </a:rPr>
-              <a:t>Partner docs</a:t>
+              <a:t>API + event schema</a:t>
             </a:r>
           </a:p>
           <a:p xmlns:a="http://schemas.openxmlformats.org/drawingml/2006/main">
@@ -6275,7 +6285,7 @@
                   <a:srgbClr val="5E6570"/>
                 </a:solidFill>
               </a:rPr>
-              <a:t>Risk integrations</a:t>
+              <a:t>Integration checklist</a:t>
             </a:r>
           </a:p>
         </p:txBody>
@@ -6408,7 +6418,7 @@
                   <a:srgbClr val="000000"/>
                 </a:solidFill>
               </a:rPr>
-              <a:t>Creditcoin volume</a:t>
+              <a:t>Reusable profile</a:t>
             </a:r>
           </a:p>
         </p:txBody>
@@ -6459,7 +6469,7 @@
                   <a:srgbClr val="5E6570"/>
                 </a:solidFill>
               </a:rPr>
-              <a:t>Proof-gated lines</a:t>
+              <a:t>Proof-opened footprint</a:t>
             </a:r>
           </a:p>
           <a:p xmlns:a="http://schemas.openxmlformats.org/drawingml/2006/main">
@@ -6528,7 +6538,7 @@
                   <a:srgbClr val="3D8DFF"/>
                 </a:solidFill>
               </a:rPr>
-              <a:t>Solo builder · contracts, relayer, web</a:t>
+              <a:t>Solo builder · contracts, worker, web</a:t>
             </a:r>
           </a:p>
         </p:txBody>

</xml_diff>